<commit_message>
Deploy preview for PR 149 🛫
</commit_message>
<xml_diff>
--- a/pr-preview/pr-149/downloads/offon-deck-template.pptx
+++ b/pr-preview/pr-149/downloads/offon-deck-template.pptx
@@ -5459,12 +5459,12 @@
         </p:nvSpPr>
         <p:spPr>
           <a:xfrm>
-            <a:off x="1172261" y="2450592"/>
-            <a:ext cx="1678838" cy="274320"/>
+            <a:off x="2318004" y="2450592"/>
+            <a:ext cx="1642262" cy="256032"/>
           </a:xfrm>
           <a:prstGeom prst="roundRect">
             <a:avLst>
-              <a:gd name="adj" fmla="val 20000"/>
+              <a:gd name="adj" fmla="val 21429"/>
             </a:avLst>
           </a:prstGeom>
           <a:solidFill>
@@ -5486,8 +5486,8 @@
         </p:nvSpPr>
         <p:spPr>
           <a:xfrm>
-            <a:off x="1172261" y="2450592"/>
-            <a:ext cx="1678838" cy="274320"/>
+            <a:off x="2318004" y="2450592"/>
+            <a:ext cx="1642262" cy="256032"/>
           </a:xfrm>
           <a:prstGeom prst="rect">
             <a:avLst/>
@@ -5503,7 +5503,7 @@
               <a:buNone/>
             </a:pPr>
             <a:r>
-              <a:rPr lang="en-US" sz="1000" dirty="0">
+              <a:rPr lang="en-US" sz="800" dirty="0">
                 <a:solidFill>
                   <a:srgbClr val="FFC034"/>
                 </a:solidFill>
@@ -5513,7 +5513,7 @@
               </a:rPr>
               <a:t>Join the community</a:t>
             </a:r>
-            <a:endParaRPr lang="en-US" sz="1000" dirty="0"/>
+            <a:endParaRPr lang="en-US" sz="800" dirty="0"/>
           </a:p>
         </p:txBody>
       </p:sp>
@@ -5525,12 +5525,12 @@
         </p:nvSpPr>
         <p:spPr>
           <a:xfrm>
-            <a:off x="2979115" y="2450592"/>
-            <a:ext cx="1004011" cy="274320"/>
+            <a:off x="4088282" y="2450592"/>
+            <a:ext cx="967435" cy="256032"/>
           </a:xfrm>
           <a:prstGeom prst="roundRect">
             <a:avLst>
-              <a:gd name="adj" fmla="val 20000"/>
+              <a:gd name="adj" fmla="val 21429"/>
             </a:avLst>
           </a:prstGeom>
           <a:solidFill>
@@ -5552,8 +5552,8 @@
         </p:nvSpPr>
         <p:spPr>
           <a:xfrm>
-            <a:off x="2979115" y="2450592"/>
-            <a:ext cx="1004011" cy="274320"/>
+            <a:off x="4088282" y="2450592"/>
+            <a:ext cx="967435" cy="256032"/>
           </a:xfrm>
           <a:prstGeom prst="rect">
             <a:avLst/>
@@ -5569,7 +5569,7 @@
               <a:buNone/>
             </a:pPr>
             <a:r>
-              <a:rPr lang="en-US" sz="1000" dirty="0">
+              <a:rPr lang="en-US" sz="800" dirty="0">
                 <a:solidFill>
                   <a:srgbClr val="F0EDE5"/>
                 </a:solidFill>
@@ -5579,7 +5579,7 @@
               </a:rPr>
               <a:t>offon.dev</a:t>
             </a:r>
-            <a:endParaRPr lang="en-US" sz="1000" dirty="0"/>
+            <a:endParaRPr lang="en-US" sz="800" dirty="0"/>
           </a:p>
         </p:txBody>
       </p:sp>
@@ -5591,12 +5591,12 @@
         </p:nvSpPr>
         <p:spPr>
           <a:xfrm>
-            <a:off x="4111142" y="2450592"/>
-            <a:ext cx="1678838" cy="274320"/>
+            <a:off x="5183734" y="2450592"/>
+            <a:ext cx="1642262" cy="256032"/>
           </a:xfrm>
           <a:prstGeom prst="roundRect">
             <a:avLst>
-              <a:gd name="adj" fmla="val 20000"/>
+              <a:gd name="adj" fmla="val 21429"/>
             </a:avLst>
           </a:prstGeom>
           <a:solidFill>
@@ -5618,8 +5618,8 @@
         </p:nvSpPr>
         <p:spPr>
           <a:xfrm>
-            <a:off x="4111142" y="2450592"/>
-            <a:ext cx="1678838" cy="274320"/>
+            <a:off x="5183734" y="2450592"/>
+            <a:ext cx="1642262" cy="256032"/>
           </a:xfrm>
           <a:prstGeom prst="rect">
             <a:avLst/>
@@ -5635,7 +5635,7 @@
               <a:buNone/>
             </a:pPr>
             <a:r>
-              <a:rPr lang="en-US" sz="1000" dirty="0">
+              <a:rPr lang="en-US" sz="800" dirty="0">
                 <a:solidFill>
                   <a:srgbClr val="F0EDE5"/>
                 </a:solidFill>
@@ -5645,7 +5645,7 @@
               </a:rPr>
               <a:t>offondev@gmail.com</a:t>
             </a:r>
-            <a:endParaRPr lang="en-US" sz="1000" dirty="0"/>
+            <a:endParaRPr lang="en-US" sz="800" dirty="0"/>
           </a:p>
         </p:txBody>
       </p:sp>
@@ -5657,12 +5657,12 @@
         </p:nvSpPr>
         <p:spPr>
           <a:xfrm>
-            <a:off x="5917997" y="2450592"/>
-            <a:ext cx="2053742" cy="274320"/>
+            <a:off x="1943100" y="2889504"/>
+            <a:ext cx="2017166" cy="256032"/>
           </a:xfrm>
           <a:prstGeom prst="roundRect">
             <a:avLst>
-              <a:gd name="adj" fmla="val 20000"/>
+              <a:gd name="adj" fmla="val 21429"/>
             </a:avLst>
           </a:prstGeom>
           <a:solidFill>
@@ -5684,8 +5684,8 @@
         </p:nvSpPr>
         <p:spPr>
           <a:xfrm>
-            <a:off x="5917997" y="2450592"/>
-            <a:ext cx="2053742" cy="274320"/>
+            <a:off x="1943100" y="2889504"/>
+            <a:ext cx="2017166" cy="256032"/>
           </a:xfrm>
           <a:prstGeom prst="rect">
             <a:avLst/>
@@ -5701,7 +5701,7 @@
               <a:buNone/>
             </a:pPr>
             <a:r>
-              <a:rPr lang="en-US" sz="1000" dirty="0">
+              <a:rPr lang="en-US" sz="800" dirty="0">
                 <a:solidFill>
                   <a:srgbClr val="F0EDE5"/>
                 </a:solidFill>
@@ -5711,7 +5711,7 @@
               </a:rPr>
               <a:t>@off-on-dev.bsky.social</a:t>
             </a:r>
-            <a:endParaRPr lang="en-US" sz="1000" dirty="0"/>
+            <a:endParaRPr lang="en-US" sz="800" dirty="0"/>
           </a:p>
         </p:txBody>
       </p:sp>
@@ -5723,12 +5723,12 @@
         </p:nvSpPr>
         <p:spPr>
           <a:xfrm>
-            <a:off x="2979115" y="2834640"/>
-            <a:ext cx="1753819" cy="274320"/>
+            <a:off x="4088282" y="2889504"/>
+            <a:ext cx="1717243" cy="256032"/>
           </a:xfrm>
           <a:prstGeom prst="roundRect">
             <a:avLst>
-              <a:gd name="adj" fmla="val 20000"/>
+              <a:gd name="adj" fmla="val 21429"/>
             </a:avLst>
           </a:prstGeom>
           <a:solidFill>
@@ -5750,8 +5750,8 @@
         </p:nvSpPr>
         <p:spPr>
           <a:xfrm>
-            <a:off x="2979115" y="2834640"/>
-            <a:ext cx="1753819" cy="274320"/>
+            <a:off x="4088282" y="2889504"/>
+            <a:ext cx="1717243" cy="256032"/>
           </a:xfrm>
           <a:prstGeom prst="rect">
             <a:avLst/>
@@ -5767,7 +5767,7 @@
               <a:buNone/>
             </a:pPr>
             <a:r>
-              <a:rPr lang="en-US" sz="1000" dirty="0">
+              <a:rPr lang="en-US" sz="800" dirty="0">
                 <a:solidFill>
                   <a:srgbClr val="F0EDE5"/>
                 </a:solidFill>
@@ -5777,7 +5777,7 @@
               </a:rPr>
               <a:t>offondev (LinkedIn)</a:t>
             </a:r>
-            <a:endParaRPr lang="en-US" sz="1000" dirty="0"/>
+            <a:endParaRPr lang="en-US" sz="800" dirty="0"/>
           </a:p>
         </p:txBody>
       </p:sp>
@@ -5789,12 +5789,12 @@
         </p:nvSpPr>
         <p:spPr>
           <a:xfrm>
-            <a:off x="4860950" y="2834640"/>
-            <a:ext cx="1303934" cy="274320"/>
+            <a:off x="5933542" y="2889504"/>
+            <a:ext cx="1267358" cy="256032"/>
           </a:xfrm>
           <a:prstGeom prst="roundRect">
             <a:avLst>
-              <a:gd name="adj" fmla="val 20000"/>
+              <a:gd name="adj" fmla="val 21429"/>
             </a:avLst>
           </a:prstGeom>
           <a:solidFill>
@@ -5816,8 +5816,8 @@
         </p:nvSpPr>
         <p:spPr>
           <a:xfrm>
-            <a:off x="4860950" y="2834640"/>
-            <a:ext cx="1303934" cy="274320"/>
+            <a:off x="5933542" y="2889504"/>
+            <a:ext cx="1267358" cy="256032"/>
           </a:xfrm>
           <a:prstGeom prst="rect">
             <a:avLst/>
@@ -5833,7 +5833,7 @@
               <a:buNone/>
             </a:pPr>
             <a:r>
-              <a:rPr lang="en-US" sz="1000" dirty="0">
+              <a:rPr lang="en-US" sz="800" dirty="0">
                 <a:solidFill>
                   <a:srgbClr val="F0EDE5"/>
                 </a:solidFill>
@@ -5843,7 +5843,7 @@
               </a:rPr>
               <a:t>@OffonDev (X)</a:t>
             </a:r>
-            <a:endParaRPr lang="en-US" sz="1000" dirty="0"/>
+            <a:endParaRPr lang="en-US" sz="800" dirty="0"/>
           </a:p>
         </p:txBody>
       </p:sp>

</xml_diff>